<commit_message>
Docs has been updated
Pitch deck and cost log updates on top of the dev_shuvo merge. Private strategy, participant and orientation files stay local (see .gitignore).
</commit_message>
<xml_diff>
--- a/docs/ClauseChain Pitch Deck.pptx
+++ b/docs/ClauseChain Pitch Deck.pptx
@@ -13,7 +13,7 @@
     <p:sldId id="258" r:id="rId4"/>
     <p:sldId id="259" r:id="rId5"/>
     <p:sldId id="260" r:id="rId6"/>
-    <p:sldId id="261" r:id="rId7"/>
+    <p:sldId id="287" r:id="rId7"/>
     <p:sldId id="262" r:id="rId8"/>
     <p:sldId id="263" r:id="rId9"/>
     <p:sldId id="264" r:id="rId10"/>
@@ -3352,7 +3352,7 @@
                 <a:ea typeface="Calibri" pitchFamily="34" charset="-122"/>
                 <a:cs typeface="Calibri" pitchFamily="34" charset="-120"/>
               </a:rPr>
-              <a:t>  ·  Team Lead, Full-stack &amp; AI Engineering</a:t>
+              <a:t>  ·  Team Lead, Full-stack &amp; AI Engineer</a:t>
             </a:r>
             <a:endParaRPr lang="en-US" sz="1600" dirty="0"/>
           </a:p>
@@ -3402,7 +3402,7 @@
                 <a:ea typeface="Calibri" pitchFamily="34" charset="-122"/>
                 <a:cs typeface="Calibri" pitchFamily="34" charset="-120"/>
               </a:rPr>
-              <a:t>  ·  Independent Legal Consultant, Legal Review</a:t>
+              <a:t>  · Legal Review</a:t>
             </a:r>
             <a:endParaRPr lang="en-US" sz="1600" dirty="0"/>
           </a:p>
@@ -3492,34 +3492,6 @@
                 <a:cs typeface="Calibri" pitchFamily="34" charset="-120"/>
               </a:rPr>
               <a:t>  ·  AI Engineer</a:t>
-            </a:r>
-            <a:endParaRPr lang="en-US" sz="1600" dirty="0"/>
-          </a:p>
-          <a:p>
-            <a:pPr marL="0" indent="0">
-              <a:buNone/>
-            </a:pPr>
-            <a:r>
-              <a:rPr lang="en-US" sz="1600" b="1" dirty="0">
-                <a:solidFill>
-                  <a:srgbClr val="FFFFFF"/>
-                </a:solidFill>
-                <a:latin typeface="Calibri" pitchFamily="34" charset="0"/>
-                <a:ea typeface="Calibri" pitchFamily="34" charset="-122"/>
-                <a:cs typeface="Calibri" pitchFamily="34" charset="-120"/>
-              </a:rPr>
-              <a:t>Farhana Borsha</a:t>
-            </a:r>
-            <a:r>
-              <a:rPr lang="en-US" sz="1400" dirty="0">
-                <a:solidFill>
-                  <a:srgbClr val="CADCFC"/>
-                </a:solidFill>
-                <a:latin typeface="Calibri" pitchFamily="34" charset="0"/>
-                <a:ea typeface="Calibri" pitchFamily="34" charset="-122"/>
-                <a:cs typeface="Calibri" pitchFamily="34" charset="-120"/>
-              </a:rPr>
-              <a:t>  ·  UI/UX Designer</a:t>
             </a:r>
             <a:endParaRPr lang="en-US" sz="1600" dirty="0"/>
           </a:p>
@@ -3997,7 +3969,7 @@
                 <a:ea typeface="Calibri" pitchFamily="34" charset="-122"/>
                 <a:cs typeface="Calibri" pitchFamily="34" charset="-120"/>
               </a:rPr>
-              <a:t>Admin-gated Runs screen starts a real sweep; Review screen walks findings with source context, gate results and refuter verdicts; decisions are written with named, role-separated reviewers.</a:t>
+              <a:t>Admin-gated Runs screen starts a real sweep; Review walks findings with source context and gate results; the RDTII Matrix shows all 60 indicator scores with reviewer decisions traced to their evidence rows.</a:t>
             </a:r>
             <a:endParaRPr lang="en-US" sz="1200" dirty="0"/>
           </a:p>
@@ -6249,7 +6221,7 @@
                 <a:ea typeface="Calibri" pitchFamily="34" charset="-122"/>
                 <a:cs typeface="Calibri" pitchFamily="34" charset="-120"/>
               </a:rPr>
-              <a:t>Per-page OCR confidence + citation-token disagreement flags are visible on affected findings in the review screen.</a:t>
+              <a:t>Per-page OCR confidence + disagreement flags in review; Round 2 adds script-aware hybrid OCR for Thai and Devanagari gazettes.</a:t>
             </a:r>
             <a:endParaRPr lang="en-US" sz="1150" dirty="0"/>
           </a:p>
@@ -8266,7 +8238,7 @@
                 <a:ea typeface="Calibri" pitchFamily="34" charset="-122"/>
                 <a:cs typeface="Calibri" pitchFamily="34" charset="-120"/>
               </a:rPr>
-              <a:t>The rubric is encoded as data (YAML), not code: indicator polarity, 0.5 tiers, the 7.5 court-order test, and 6.5 treaty evidence all flow through one generic pipeline — the same design that scales to the 8 finals economies.</a:t>
+              <a:t>The rubric is encoded as data (YAML), not code: indicator polarity, 0.5 tiers, the 7.5 court-order test, and 6.5 treaty evidence all flow through one generic pipeline — the same design that now runs six economies (TH · IN · ID added as data only).</a:t>
             </a:r>
             <a:endParaRPr lang="en-US" sz="1250" dirty="0"/>
           </a:p>
@@ -8839,7 +8811,7 @@
                 <a:ea typeface="Calibri" pitchFamily="34" charset="-122"/>
                 <a:cs typeface="Calibri" pitchFamily="34" charset="-120"/>
               </a:rPr>
-              <a:t>Six envelopes: measured cost, elapsed time, model route, warnings — per run.</a:t>
+              <a:t>Twelve envelopes: measured cost, elapsed time, model route, warnings — per run.</a:t>
             </a:r>
             <a:endParaRPr lang="en-US" sz="1200" dirty="0"/>
           </a:p>
@@ -8882,7 +8854,7 @@
                 <a:ea typeface="Calibri" pitchFamily="34" charset="-122"/>
                 <a:cs typeface="Calibri" pitchFamily="34" charset="-120"/>
               </a:rPr>
-              <a:t>$0.08–$0.34 per economy-pillar, printed with the model route that produced it</a:t>
+              <a:t>$0.05–$0.80 per economy-pillar, printed with the model route that produced it</a:t>
             </a:r>
             <a:endParaRPr lang="en-US" sz="1050" dirty="0"/>
           </a:p>
@@ -10890,7 +10862,7 @@
                 <a:ea typeface="Calibri" pitchFamily="34" charset="-122"/>
                 <a:cs typeface="Calibri" pitchFamily="34" charset="-120"/>
               </a:rPr>
-              <a:t>configs/jurisdictions/th.yaml  (all it takes)</a:t>
+              <a:t>configs/jurisdictions/th.yaml  (as shipped, Round 2)</a:t>
             </a:r>
             <a:endParaRPr lang="en-US" sz="1200" dirty="0"/>
           </a:p>
@@ -11264,7 +11236,7 @@
                 <a:ea typeface="Calibri" pitchFamily="34" charset="-122"/>
                 <a:cs typeface="Calibri" pitchFamily="34" charset="-120"/>
               </a:rPr>
-              <a:t>Section grammars are named data profiles: treaty and Malay shipped this round; "Pasal", "Статья", "มาตรา" are one dictionary entry each.</a:t>
+              <a:t>Section grammars are named data profiles: treaty, Malay, "มาตรา", "धारा/Rule" and "Pasal/ayat" have all shipped as dictionary entries.</a:t>
             </a:r>
             <a:endParaRPr lang="en-US" sz="1100" dirty="0"/>
           </a:p>
@@ -11327,7 +11299,7 @@
                 <a:ea typeface="Calibri" pitchFamily="34" charset="-122"/>
                 <a:cs typeface="Calibri" pitchFamily="34" charset="-120"/>
               </a:rPr>
-              <a:t>Proof: this round, treaties + subsidiary legislation + Malay grammar were added mid-sprint as configuration — the engine diff was generic plumbing only.</a:t>
+              <a:t>Proof: Thailand, India and Indonesia went live exactly this way — three YAML packs + seed rows; full sweeps completed against the Round-2 gold.</a:t>
             </a:r>
             <a:endParaRPr lang="en-US" sz="1100" dirty="0"/>
           </a:p>
@@ -11345,7 +11317,7 @@
                 <a:ea typeface="Calibri" pitchFamily="34" charset="-122"/>
                 <a:cs typeface="Calibri" pitchFamily="34" charset="-120"/>
               </a:rPr>
-              <a:t>The government-verified Round-2 gold (CN·IN·ID·LA·MN·RU·TH) is already ingested as the 8-economy eval baseline.</a:t>
+              <a:t>The government-verified Round-2 gold is ingested — and TH · IN · ID sweeps have already been evaluated against it.</a:t>
             </a:r>
             <a:endParaRPr lang="en-US" sz="1100" dirty="0"/>
           </a:p>
@@ -11465,7 +11437,7 @@
                 <a:ea typeface="Calibri" pitchFamily="34" charset="-122"/>
                 <a:cs typeface="Calibri" pitchFamily="34" charset="-120"/>
               </a:rPr>
-              <a:t>FROM 3 ECONOMIES TO THE REGION</a:t>
+              <a:t>FROM 6 ECONOMIES TO THE REGION</a:t>
             </a:r>
             <a:endParaRPr lang="en-US" sz="1200" dirty="0"/>
           </a:p>
@@ -11608,7 +11580,7 @@
                 <a:ea typeface="Calibri" pitchFamily="34" charset="-122"/>
                 <a:cs typeface="Calibri" pitchFamily="34" charset="-120"/>
               </a:rPr>
-              <a:t>New economy = data, not code: a jurisdiction YAML (portals, citation grammar, status assertions) + seed rows. Extractors are format-based; grammars are named profiles ("Pasal", "Статья", "มาตรา" next).</a:t>
+              <a:t>New economy = data, not code — proven: TH, IN and ID were onboarded with three YAML packs + seed rows. Extractors are format-based; "มาตรา", "धारा" and "Pasal" grammars shipped ("Статья" next).</a:t>
             </a:r>
             <a:endParaRPr lang="en-US" sz="1150" dirty="0"/>
           </a:p>
@@ -11629,7 +11601,7 @@
                 <a:ea typeface="Calibri" pitchFamily="34" charset="-122"/>
                 <a:cs typeface="Calibri" pitchFamily="34" charset="-120"/>
               </a:rPr>
-              <a:t>Finals-ready gold: the government-verified Round-2 database (CN·IN·ID·LA·MN·RU·TH) is already ingested as the evaluation baseline for the 8-economy expansion.</a:t>
+              <a:t>Finals-ready: three Round-2 economies fully swept and evaluated against the government-verified gold; five more follow the same data-only path.</a:t>
             </a:r>
             <a:endParaRPr lang="en-US" sz="1150" dirty="0"/>
           </a:p>
@@ -11650,7 +11622,7 @@
                 <a:ea typeface="Calibri" pitchFamily="34" charset="-122"/>
                 <a:cs typeface="Calibri" pitchFamily="34" charset="-120"/>
               </a:rPr>
-              <a:t>Multilingual by architecture: BGE-M3 cross-lingual retrieval, original-language verbatim + appended English column, per-language section grammars.</a:t>
+              <a:t>Multilingual by architecture: script-aware hybrid OCR (Thai / Devanagari live), cross-lingual retrieval, original-language verbatim + English column, per-language grammars.</a:t>
             </a:r>
             <a:endParaRPr lang="en-US" sz="1150" dirty="0"/>
           </a:p>
@@ -11976,7 +11948,7 @@
                 <a:ea typeface="Calibri" pitchFamily="34" charset="-122"/>
                 <a:cs typeface="Calibri" pitchFamily="34" charset="-120"/>
               </a:rPr>
-              <a:t>THE CHAMPIONSHIP CASE</a:t>
+              <a:t>OUR CASE</a:t>
             </a:r>
             <a:endParaRPr lang="en-US" sz="1300" dirty="0"/>
           </a:p>
@@ -12015,7 +11987,40 @@
                 <a:ea typeface="Titillium Web" pitchFamily="34" charset="-122"/>
                 <a:cs typeface="Titillium Web" pitchFamily="34" charset="-120"/>
               </a:rPr>
-              <a:t>Why ClauseChain should win</a:t>
+              <a:t>Why </a:t>
+            </a:r>
+            <a:r>
+              <a:rPr lang="en-US" sz="3400" b="1" dirty="0" err="1">
+                <a:solidFill>
+                  <a:srgbClr val="FFFFFF"/>
+                </a:solidFill>
+                <a:latin typeface="Titillium Web" pitchFamily="34" charset="0"/>
+                <a:ea typeface="Titillium Web" pitchFamily="34" charset="-122"/>
+                <a:cs typeface="Titillium Web" pitchFamily="34" charset="-120"/>
+              </a:rPr>
+              <a:t>ClauseChain</a:t>
+            </a:r>
+            <a:r>
+              <a:rPr lang="en-US" sz="3400" b="1" dirty="0">
+                <a:solidFill>
+                  <a:srgbClr val="FFFFFF"/>
+                </a:solidFill>
+                <a:latin typeface="Titillium Web" pitchFamily="34" charset="0"/>
+                <a:ea typeface="Titillium Web" pitchFamily="34" charset="-122"/>
+                <a:cs typeface="Titillium Web" pitchFamily="34" charset="-120"/>
+              </a:rPr>
+              <a:t> can be </a:t>
+            </a:r>
+            <a:r>
+              <a:rPr lang="en-US" sz="3400" b="1">
+                <a:solidFill>
+                  <a:srgbClr val="FFFFFF"/>
+                </a:solidFill>
+                <a:latin typeface="Titillium Web" pitchFamily="34" charset="0"/>
+                <a:ea typeface="Titillium Web" pitchFamily="34" charset="-122"/>
+                <a:cs typeface="Titillium Web" pitchFamily="34" charset="-120"/>
+              </a:rPr>
+              <a:t>an excellent Solution</a:t>
             </a:r>
             <a:endParaRPr lang="en-US" sz="3400" dirty="0"/>
           </a:p>
@@ -12076,7 +12081,7 @@
                 <a:ea typeface="Calibri" pitchFamily="34" charset="-122"/>
                 <a:cs typeface="Calibri" pitchFamily="34" charset="-120"/>
               </a:rPr>
-              <a:t>SUBSTANTIVE ACCURACY · 40%</a:t>
+              <a:t>SUBSTANTIVE ACCURACY </a:t>
             </a:r>
             <a:endParaRPr lang="en-US" sz="1400" dirty="0"/>
           </a:p>
@@ -12119,7 +12124,7 @@
                 <a:ea typeface="Calibri" pitchFamily="34" charset="-122"/>
                 <a:cs typeface="Calibri" pitchFamily="34" charset="-120"/>
               </a:rPr>
-              <a:t>74 provision-level NEW findings beyond the sample kit — the 20-point lever, systematically harvested</a:t>
+              <a:t>167 provision-level NEW candidates across six economies — 96 already carry named human decisions</a:t>
             </a:r>
             <a:endParaRPr lang="en-US" sz="1200" dirty="0"/>
           </a:p>
@@ -12243,7 +12248,7 @@
                 <a:ea typeface="Calibri" pitchFamily="34" charset="-122"/>
                 <a:cs typeface="Calibri" pitchFamily="34" charset="-120"/>
               </a:rPr>
-              <a:t>TECHNICAL RESILIENCE · 30%</a:t>
+              <a:t>TECHNICAL RESILIENCE</a:t>
             </a:r>
             <a:endParaRPr lang="en-US" sz="1400" dirty="0"/>
           </a:p>
@@ -12307,7 +12312,7 @@
                 <a:ea typeface="Calibri" pitchFamily="34" charset="-122"/>
                 <a:cs typeface="Calibri" pitchFamily="34" charset="-120"/>
               </a:rPr>
-              <a:t>Scanned gazettes: OCR with per-page confidence + statutory glyph repair; bilingual Malay grammar</a:t>
+              <a:t>Scanned gazettes: hybrid script-aware OCR (Thai/Devanagari live) with per-page confidence + glyph repair</a:t>
             </a:r>
             <a:endParaRPr lang="en-US" sz="1200" dirty="0"/>
           </a:p>
@@ -12410,7 +12415,7 @@
                 <a:ea typeface="Calibri" pitchFamily="34" charset="-122"/>
                 <a:cs typeface="Calibri" pitchFamily="34" charset="-120"/>
               </a:rPr>
-              <a:t>ARCHITECTURE · 30%</a:t>
+              <a:t>ARCHITECTURE</a:t>
             </a:r>
             <a:endParaRPr lang="en-US" sz="1400" dirty="0"/>
           </a:p>
@@ -12495,7 +12500,7 @@
                 <a:ea typeface="Calibri" pitchFamily="34" charset="-122"/>
                 <a:cs typeface="Calibri" pitchFamily="34" charset="-120"/>
               </a:rPr>
-              <a:t>Measured cost: US$1.16 for the entire 3-economy sweep (≈ $0.01 per document)</a:t>
+              <a:t>Measured cost: US$3.12 across all twelve economy-pillar runs — printed per run</a:t>
             </a:r>
             <a:endParaRPr lang="en-US" sz="1200" dirty="0"/>
           </a:p>
@@ -12516,7 +12521,7 @@
                 <a:ea typeface="Calibri" pitchFamily="34" charset="-122"/>
                 <a:cs typeface="Calibri" pitchFamily="34" charset="-120"/>
               </a:rPr>
-              <a:t>Adding an economy or pillar = one YAML + seed rows; finals gold already ingested</a:t>
+              <a:t>Adding an economy = one YAML + seed rows — TH · IN · ID shipped exactly that way</a:t>
             </a:r>
             <a:endParaRPr lang="en-US" sz="1200" dirty="0"/>
           </a:p>
@@ -13075,7 +13080,7 @@
                 <a:ea typeface="Calibri" pitchFamily="34" charset="-122"/>
                 <a:cs typeface="Calibri" pitchFamily="34" charset="-120"/>
               </a:rPr>
-              <a:t>GPT nano/mini tiers via API (operator key) · local Ollama fallback profile</a:t>
+              <a:t>GPT bulk/escalation tiers via OpenRouter · local Ollama fallback profile</a:t>
             </a:r>
             <a:endParaRPr lang="en-US" sz="1050" dirty="0"/>
           </a:p>
@@ -15464,7 +15469,7 @@
                 <a:ea typeface="Calibri" pitchFamily="34" charset="-122"/>
                 <a:cs typeface="Calibri" pitchFamily="34" charset="-120"/>
               </a:rPr>
-              <a:t>SSO · lom.agc · legislation.gov.au · gazettes · MITI/ESG treaty registers</a:t>
+              <a:t>SSO · lom.agc · legislation.gov.au · ratchakitcha · eGazette · BPK/JDIH · treaties</a:t>
             </a:r>
             <a:endParaRPr lang="en-US" sz="1200" dirty="0"/>
           </a:p>
@@ -16032,7 +16037,7 @@
                 <a:ea typeface="Calibri" pitchFamily="34" charset="-122"/>
                 <a:cs typeface="Calibri" pitchFamily="34" charset="-120"/>
               </a:rPr>
-              <a:t>Hybrid retrieval → LLM screen/map (nano→mini escalation) → gates G1–G9 → NEW/KNOWN diff</a:t>
+              <a:t>Hybrid retrieval → LLM screen/map (bulk→escalation tiers) → gates G1–G9 → NEW/KNOWN diff</a:t>
             </a:r>
             <a:endParaRPr lang="en-US" sz="1200" dirty="0"/>
           </a:p>
@@ -16347,8 +16352,8 @@
         </p:nvSpPr>
         <p:spPr>
           <a:xfrm>
-            <a:off x="548640" y="1417320"/>
-            <a:ext cx="5486400" cy="4846320"/>
+            <a:off x="548640" y="1422400"/>
+            <a:ext cx="5486400" cy="5029200"/>
           </a:xfrm>
           <a:prstGeom prst="roundRect">
             <a:avLst>
@@ -16360,6 +16365,13 @@
           </a:solidFill>
           <a:ln/>
         </p:spPr>
+        <p:txBody>
+          <a:bodyPr/>
+          <a:lstStyle/>
+          <a:p>
+            <a:endParaRPr lang="en-BD"/>
+          </a:p>
+        </p:txBody>
       </p:sp>
       <p:sp>
         <p:nvSpPr>
@@ -16402,133 +16414,14 @@
       </p:sp>
       <p:sp>
         <p:nvSpPr>
-          <p:cNvPr id="6" name="Text 4"/>
-          <p:cNvSpPr/>
-          <p:nvPr/>
-        </p:nvSpPr>
-        <p:spPr>
-          <a:xfrm>
-            <a:off x="822960" y="1965960"/>
-            <a:ext cx="4937760" cy="4114800"/>
-          </a:xfrm>
-          <a:prstGeom prst="rect">
-            <a:avLst/>
-          </a:prstGeom>
-          <a:noFill/>
-          <a:ln/>
-        </p:spPr>
-        <p:txBody>
-          <a:bodyPr wrap="square" rtlCol="0" anchor="t"/>
-          <a:lstStyle/>
-          <a:p>
-            <a:pPr marL="0" indent="0">
-              <a:spcAft>
-                <a:spcPts val="600"/>
-              </a:spcAft>
-              <a:buNone/>
-            </a:pPr>
-            <a:r>
-              <a:rPr lang="en-US" sz="1200" dirty="0">
-                <a:solidFill>
-                  <a:srgbClr val="24303C"/>
-                </a:solidFill>
-                <a:latin typeface="Calibri" pitchFamily="34" charset="0"/>
-                <a:ea typeface="Calibri" pitchFamily="34" charset="-122"/>
-                <a:cs typeface="Calibri" pitchFamily="34" charset="-120"/>
-              </a:rPr>
-              <a:t>Engine — Python 3.12 (PSF), httpx/pydantic/numpy (BSD/MIT), pymupdf (AGPL, unmodified library use)</a:t>
-            </a:r>
-            <a:endParaRPr lang="en-US" sz="1200" dirty="0"/>
-          </a:p>
-          <a:p>
-            <a:pPr marL="0" indent="0">
-              <a:spcAft>
-                <a:spcPts val="600"/>
-              </a:spcAft>
-              <a:buNone/>
-            </a:pPr>
-            <a:r>
-              <a:rPr lang="en-US" sz="1200" dirty="0">
-                <a:solidFill>
-                  <a:srgbClr val="24303C"/>
-                </a:solidFill>
-                <a:latin typeface="Calibri" pitchFamily="34" charset="0"/>
-                <a:ea typeface="Calibri" pitchFamily="34" charset="-122"/>
-                <a:cs typeface="Calibri" pitchFamily="34" charset="-120"/>
-              </a:rPr>
-              <a:t>Graph — SQLite + FTS5 (public domain) default · Neo4j Community (GPLv3) optional via GRAPH_BACKEND</a:t>
-            </a:r>
-            <a:endParaRPr lang="en-US" sz="1200" dirty="0"/>
-          </a:p>
-          <a:p>
-            <a:pPr marL="0" indent="0">
-              <a:spcAft>
-                <a:spcPts val="600"/>
-              </a:spcAft>
-              <a:buNone/>
-            </a:pPr>
-            <a:r>
-              <a:rPr lang="en-US" sz="1200" dirty="0">
-                <a:solidFill>
-                  <a:srgbClr val="24303C"/>
-                </a:solidFill>
-                <a:latin typeface="Calibri" pitchFamily="34" charset="0"/>
-                <a:ea typeface="Calibri" pitchFamily="34" charset="-122"/>
-                <a:cs typeface="Calibri" pitchFamily="34" charset="-120"/>
-              </a:rPr>
-              <a:t>Models — profile-swappable via models.yaml: cloud GPT nano/mini tiers (operator key) or local Ollama; BGE-M3 embeddings (MIT); local OCR</a:t>
-            </a:r>
-            <a:endParaRPr lang="en-US" sz="1200" dirty="0"/>
-          </a:p>
-          <a:p>
-            <a:pPr marL="0" indent="0">
-              <a:spcAft>
-                <a:spcPts val="600"/>
-              </a:spcAft>
-              <a:buNone/>
-            </a:pPr>
-            <a:r>
-              <a:rPr lang="en-US" sz="1200" dirty="0">
-                <a:solidFill>
-                  <a:srgbClr val="24303C"/>
-                </a:solidFill>
-                <a:latin typeface="Calibri" pitchFamily="34" charset="0"/>
-                <a:ea typeface="Calibri" pitchFamily="34" charset="-122"/>
-                <a:cs typeface="Calibri" pitchFamily="34" charset="-120"/>
-              </a:rPr>
-              <a:t>App — Django + DRF (BSD), Next.js/React (MIT), PostgreSQL (PostgreSQL licence)</a:t>
-            </a:r>
-            <a:endParaRPr lang="en-US" sz="1200" dirty="0"/>
-          </a:p>
-          <a:p>
-            <a:pPr marL="0" indent="0">
-              <a:buNone/>
-            </a:pPr>
-            <a:r>
-              <a:rPr lang="en-US" sz="1200" dirty="0">
-                <a:solidFill>
-                  <a:srgbClr val="24303C"/>
-                </a:solidFill>
-                <a:latin typeface="Calibri" pitchFamily="34" charset="0"/>
-                <a:ea typeface="Calibri" pitchFamily="34" charset="-122"/>
-                <a:cs typeface="Calibri" pitchFamily="34" charset="-120"/>
-              </a:rPr>
-              <a:t>Ops — systemd + nginx on plain Linux; no proprietary services required; Path A runs fully offline from a clean clone</a:t>
-            </a:r>
-            <a:endParaRPr lang="en-US" sz="1200" dirty="0"/>
-          </a:p>
-        </p:txBody>
-      </p:sp>
-      <p:sp>
-        <p:nvSpPr>
           <p:cNvPr id="7" name="Shape 5"/>
           <p:cNvSpPr/>
           <p:nvPr/>
         </p:nvSpPr>
         <p:spPr>
           <a:xfrm>
-            <a:off x="6309360" y="1417320"/>
-            <a:ext cx="5303520" cy="4846320"/>
+            <a:off x="6309360" y="1422400"/>
+            <a:ext cx="5303520" cy="5029200"/>
           </a:xfrm>
           <a:prstGeom prst="roundRect">
             <a:avLst>
@@ -16540,6 +16433,13 @@
           </a:solidFill>
           <a:ln/>
         </p:spPr>
+        <p:txBody>
+          <a:bodyPr/>
+          <a:lstStyle/>
+          <a:p>
+            <a:endParaRPr lang="en-BD"/>
+          </a:p>
+        </p:txBody>
       </p:sp>
       <p:sp>
         <p:nvSpPr>
@@ -16577,130 +16477,6 @@
               <a:t>WHAT MAKES IT DIFFERENT</a:t>
             </a:r>
             <a:endParaRPr lang="en-US" sz="1300" dirty="0"/>
-          </a:p>
-        </p:txBody>
-      </p:sp>
-      <p:sp>
-        <p:nvSpPr>
-          <p:cNvPr id="9" name="Text 7"/>
-          <p:cNvSpPr/>
-          <p:nvPr/>
-        </p:nvSpPr>
-        <p:spPr>
-          <a:xfrm>
-            <a:off x="6583680" y="1965960"/>
-            <a:ext cx="4754880" cy="4114800"/>
-          </a:xfrm>
-          <a:prstGeom prst="rect">
-            <a:avLst/>
-          </a:prstGeom>
-          <a:noFill/>
-          <a:ln/>
-        </p:spPr>
-        <p:txBody>
-          <a:bodyPr wrap="square" rtlCol="0" anchor="t"/>
-          <a:lstStyle/>
-          <a:p>
-            <a:pPr marL="342900" indent="-342900">
-              <a:spcAft>
-                <a:spcPts val="800"/>
-              </a:spcAft>
-              <a:buSzPct val="100000"/>
-              <a:buChar char="•"/>
-            </a:pPr>
-            <a:r>
-              <a:rPr lang="en-US" sz="1200" dirty="0">
-                <a:solidFill>
-                  <a:srgbClr val="24303C"/>
-                </a:solidFill>
-                <a:latin typeface="Calibri" pitchFamily="34" charset="0"/>
-                <a:ea typeface="Calibri" pitchFamily="34" charset="-122"/>
-                <a:cs typeface="Calibri" pitchFamily="34" charset="-120"/>
-              </a:rPr>
-              <a:t>Proof chain, not just answers — every row: archived bytes + SHA-256 + span-level citation proof + gate results</a:t>
-            </a:r>
-            <a:endParaRPr lang="en-US" sz="1200" dirty="0"/>
-          </a:p>
-          <a:p>
-            <a:pPr marL="342900" indent="-342900">
-              <a:spcAft>
-                <a:spcPts val="800"/>
-              </a:spcAft>
-              <a:buSzPct val="100000"/>
-              <a:buChar char="•"/>
-            </a:pPr>
-            <a:r>
-              <a:rPr lang="en-US" sz="1200" dirty="0">
-                <a:solidFill>
-                  <a:srgbClr val="24303C"/>
-                </a:solidFill>
-                <a:latin typeface="Calibri" pitchFamily="34" charset="0"/>
-                <a:ea typeface="Calibri" pitchFamily="34" charset="-122"/>
-                <a:cs typeface="Calibri" pitchFamily="34" charset="-120"/>
-              </a:rPr>
-              <a:t>Rubric-as-code — indicator polarity, 0.5 tiers, exclusions and treaty scoping live in YAML data, never in code</a:t>
-            </a:r>
-            <a:endParaRPr lang="en-US" sz="1200" dirty="0"/>
-          </a:p>
-          <a:p>
-            <a:pPr marL="342900" indent="-342900">
-              <a:spcAft>
-                <a:spcPts val="800"/>
-              </a:spcAft>
-              <a:buSzPct val="100000"/>
-              <a:buChar char="•"/>
-            </a:pPr>
-            <a:r>
-              <a:rPr lang="en-US" sz="1200" dirty="0">
-                <a:solidFill>
-                  <a:srgbClr val="24303C"/>
-                </a:solidFill>
-                <a:latin typeface="Calibri" pitchFamily="34" charset="0"/>
-                <a:ea typeface="Calibri" pitchFamily="34" charset="-122"/>
-                <a:cs typeface="Calibri" pitchFamily="34" charset="-120"/>
-              </a:rPr>
-              <a:t>Honest failure — dead links become ACQUISITION_UNRESOLVED facts that BLOCK absence conclusions (network failure is never legal absence)</a:t>
-            </a:r>
-            <a:endParaRPr lang="en-US" sz="1200" dirty="0"/>
-          </a:p>
-          <a:p>
-            <a:pPr marL="342900" indent="-342900">
-              <a:spcAft>
-                <a:spcPts val="800"/>
-              </a:spcAft>
-              <a:buSzPct val="100000"/>
-              <a:buChar char="•"/>
-            </a:pPr>
-            <a:r>
-              <a:rPr lang="en-US" sz="1200" dirty="0">
-                <a:solidFill>
-                  <a:srgbClr val="24303C"/>
-                </a:solidFill>
-                <a:latin typeface="Calibri" pitchFamily="34" charset="0"/>
-                <a:ea typeface="Calibri" pitchFamily="34" charset="-122"/>
-                <a:cs typeface="Calibri" pitchFamily="34" charset="-120"/>
-              </a:rPr>
-              <a:t>Processing fingerprints — source sha + extractor version + grammar profile gate every cache reuse; parser changes force re-extraction</a:t>
-            </a:r>
-            <a:endParaRPr lang="en-US" sz="1200" dirty="0"/>
-          </a:p>
-          <a:p>
-            <a:pPr marL="342900" indent="-342900">
-              <a:buSzPct val="100000"/>
-              <a:buChar char="•"/>
-            </a:pPr>
-            <a:r>
-              <a:rPr lang="en-US" sz="1200" dirty="0">
-                <a:solidFill>
-                  <a:srgbClr val="24303C"/>
-                </a:solidFill>
-                <a:latin typeface="Calibri" pitchFamily="34" charset="0"/>
-                <a:ea typeface="Calibri" pitchFamily="34" charset="-122"/>
-                <a:cs typeface="Calibri" pitchFamily="34" charset="-120"/>
-              </a:rPr>
-              <a:t>Gold-audit tripwire — we detected planted errors in the provided Malaysia gold data and filed corrections with receipts</a:t>
-            </a:r>
-            <a:endParaRPr lang="en-US" sz="1200" dirty="0"/>
           </a:p>
         </p:txBody>
       </p:sp>
@@ -16752,7 +16528,1152 @@
           </a:prstGeom>
         </p:spPr>
       </p:pic>
+      <p:sp>
+        <p:nvSpPr>
+          <p:cNvPr id="200" name="Info 200"/>
+          <p:cNvSpPr/>
+          <p:nvPr/>
+        </p:nvSpPr>
+        <p:spPr>
+          <a:xfrm>
+            <a:off x="825500" y="2006600"/>
+            <a:ext cx="558800" cy="685800"/>
+          </a:xfrm>
+          <a:prstGeom prst="roundRect">
+            <a:avLst/>
+          </a:prstGeom>
+          <a:solidFill>
+            <a:srgbClr val="1F7A8C"/>
+          </a:solidFill>
+          <a:ln>
+            <a:noFill/>
+          </a:ln>
+        </p:spPr>
+        <p:txBody>
+          <a:bodyPr wrap="square" lIns="114300" tIns="50800" rIns="114300" bIns="50800" anchor="ctr">
+            <a:normAutofit/>
+          </a:bodyPr>
+          <a:lstStyle/>
+          <a:p>
+            <a:pPr algn="ctr">
+              <a:buNone/>
+            </a:pPr>
+            <a:r>
+              <a:rPr lang="en-GB" sz="1400" b="1" dirty="0">
+                <a:solidFill>
+                  <a:srgbClr val="FFFFFF"/>
+                </a:solidFill>
+                <a:latin typeface="Calibri"/>
+              </a:rPr>
+              <a:t>01</a:t>
+            </a:r>
+          </a:p>
+        </p:txBody>
+      </p:sp>
+      <p:sp>
+        <p:nvSpPr>
+          <p:cNvPr id="201" name="Info 201"/>
+          <p:cNvSpPr/>
+          <p:nvPr/>
+        </p:nvSpPr>
+        <p:spPr>
+          <a:xfrm>
+            <a:off x="1460500" y="2006600"/>
+            <a:ext cx="4305300" cy="685800"/>
+          </a:xfrm>
+          <a:prstGeom prst="roundRect">
+            <a:avLst/>
+          </a:prstGeom>
+          <a:solidFill>
+            <a:srgbClr val="FFFFFF"/>
+          </a:solidFill>
+          <a:ln>
+            <a:noFill/>
+          </a:ln>
+        </p:spPr>
+        <p:txBody>
+          <a:bodyPr wrap="square" lIns="114300" tIns="50800" rIns="114300" bIns="50800" anchor="ctr">
+            <a:normAutofit/>
+          </a:bodyPr>
+          <a:lstStyle/>
+          <a:p>
+            <a:pPr algn="l">
+              <a:buNone/>
+            </a:pPr>
+            <a:r>
+              <a:rPr lang="en-GB" sz="1400" b="1" dirty="0">
+                <a:solidFill>
+                  <a:srgbClr val="14313D"/>
+                </a:solidFill>
+                <a:latin typeface="Calibri"/>
+              </a:rPr>
+              <a:t>Engine</a:t>
+            </a:r>
+          </a:p>
+          <a:p>
+            <a:pPr algn="l">
+              <a:buNone/>
+            </a:pPr>
+            <a:r>
+              <a:rPr lang="en-GB" sz="1000" dirty="0">
+                <a:solidFill>
+                  <a:srgbClr val="4A5A66"/>
+                </a:solidFill>
+                <a:latin typeface="Calibri"/>
+              </a:rPr>
+              <a:t>Python 3.12 · httpx / pydantic / numpy · pymupdf</a:t>
+            </a:r>
+          </a:p>
+        </p:txBody>
+      </p:sp>
+      <p:sp>
+        <p:nvSpPr>
+          <p:cNvPr id="202" name="Info 202"/>
+          <p:cNvSpPr/>
+          <p:nvPr/>
+        </p:nvSpPr>
+        <p:spPr>
+          <a:xfrm>
+            <a:off x="825500" y="2781300"/>
+            <a:ext cx="558800" cy="685800"/>
+          </a:xfrm>
+          <a:prstGeom prst="roundRect">
+            <a:avLst/>
+          </a:prstGeom>
+          <a:solidFill>
+            <a:srgbClr val="1F7A8C"/>
+          </a:solidFill>
+          <a:ln>
+            <a:noFill/>
+          </a:ln>
+        </p:spPr>
+        <p:txBody>
+          <a:bodyPr wrap="square" lIns="114300" tIns="50800" rIns="114300" bIns="50800" anchor="ctr">
+            <a:normAutofit/>
+          </a:bodyPr>
+          <a:lstStyle/>
+          <a:p>
+            <a:pPr algn="ctr">
+              <a:buNone/>
+            </a:pPr>
+            <a:r>
+              <a:rPr lang="en-GB" sz="1400" b="1" dirty="0">
+                <a:solidFill>
+                  <a:srgbClr val="FFFFFF"/>
+                </a:solidFill>
+                <a:latin typeface="Calibri"/>
+              </a:rPr>
+              <a:t>02</a:t>
+            </a:r>
+          </a:p>
+        </p:txBody>
+      </p:sp>
+      <p:sp>
+        <p:nvSpPr>
+          <p:cNvPr id="203" name="Info 203"/>
+          <p:cNvSpPr/>
+          <p:nvPr/>
+        </p:nvSpPr>
+        <p:spPr>
+          <a:xfrm>
+            <a:off x="1460500" y="2781300"/>
+            <a:ext cx="4305300" cy="685800"/>
+          </a:xfrm>
+          <a:prstGeom prst="roundRect">
+            <a:avLst/>
+          </a:prstGeom>
+          <a:solidFill>
+            <a:srgbClr val="FFFFFF"/>
+          </a:solidFill>
+          <a:ln>
+            <a:noFill/>
+          </a:ln>
+        </p:spPr>
+        <p:txBody>
+          <a:bodyPr wrap="square" lIns="114300" tIns="50800" rIns="114300" bIns="50800" anchor="ctr">
+            <a:normAutofit/>
+          </a:bodyPr>
+          <a:lstStyle/>
+          <a:p>
+            <a:pPr algn="l">
+              <a:buNone/>
+            </a:pPr>
+            <a:r>
+              <a:rPr lang="en-GB" sz="1400" b="1" dirty="0">
+                <a:solidFill>
+                  <a:srgbClr val="14313D"/>
+                </a:solidFill>
+                <a:latin typeface="Calibri"/>
+              </a:rPr>
+              <a:t>Graph</a:t>
+            </a:r>
+          </a:p>
+          <a:p>
+            <a:pPr algn="l">
+              <a:buNone/>
+            </a:pPr>
+            <a:r>
+              <a:rPr lang="en-GB" sz="1000" dirty="0">
+                <a:solidFill>
+                  <a:srgbClr val="4A5A66"/>
+                </a:solidFill>
+                <a:latin typeface="Calibri"/>
+              </a:rPr>
+              <a:t>SQLite + FTS5 default · Neo4j Community optional</a:t>
+            </a:r>
+          </a:p>
+        </p:txBody>
+      </p:sp>
+      <p:sp>
+        <p:nvSpPr>
+          <p:cNvPr id="204" name="Info 204"/>
+          <p:cNvSpPr/>
+          <p:nvPr/>
+        </p:nvSpPr>
+        <p:spPr>
+          <a:xfrm>
+            <a:off x="825500" y="3556000"/>
+            <a:ext cx="558800" cy="685800"/>
+          </a:xfrm>
+          <a:prstGeom prst="roundRect">
+            <a:avLst/>
+          </a:prstGeom>
+          <a:solidFill>
+            <a:srgbClr val="1F7A8C"/>
+          </a:solidFill>
+          <a:ln>
+            <a:noFill/>
+          </a:ln>
+        </p:spPr>
+        <p:txBody>
+          <a:bodyPr wrap="square" lIns="114300" tIns="50800" rIns="114300" bIns="50800" anchor="ctr">
+            <a:normAutofit/>
+          </a:bodyPr>
+          <a:lstStyle/>
+          <a:p>
+            <a:pPr algn="ctr">
+              <a:buNone/>
+            </a:pPr>
+            <a:r>
+              <a:rPr lang="en-GB" sz="1400" b="1" dirty="0">
+                <a:solidFill>
+                  <a:srgbClr val="FFFFFF"/>
+                </a:solidFill>
+                <a:latin typeface="Calibri"/>
+              </a:rPr>
+              <a:t>03</a:t>
+            </a:r>
+          </a:p>
+        </p:txBody>
+      </p:sp>
+      <p:sp>
+        <p:nvSpPr>
+          <p:cNvPr id="205" name="Info 205"/>
+          <p:cNvSpPr/>
+          <p:nvPr/>
+        </p:nvSpPr>
+        <p:spPr>
+          <a:xfrm>
+            <a:off x="1460500" y="3556000"/>
+            <a:ext cx="4305300" cy="685800"/>
+          </a:xfrm>
+          <a:prstGeom prst="roundRect">
+            <a:avLst/>
+          </a:prstGeom>
+          <a:solidFill>
+            <a:srgbClr val="FFFFFF"/>
+          </a:solidFill>
+          <a:ln>
+            <a:noFill/>
+          </a:ln>
+        </p:spPr>
+        <p:txBody>
+          <a:bodyPr wrap="square" lIns="114300" tIns="50800" rIns="114300" bIns="50800" anchor="ctr">
+            <a:normAutofit/>
+          </a:bodyPr>
+          <a:lstStyle/>
+          <a:p>
+            <a:pPr algn="l">
+              <a:buNone/>
+            </a:pPr>
+            <a:r>
+              <a:rPr lang="en-GB" sz="1400" b="1" dirty="0">
+                <a:solidFill>
+                  <a:srgbClr val="14313D"/>
+                </a:solidFill>
+                <a:latin typeface="Calibri"/>
+              </a:rPr>
+              <a:t>Models</a:t>
+            </a:r>
+          </a:p>
+          <a:p>
+            <a:pPr algn="l">
+              <a:buNone/>
+            </a:pPr>
+            <a:r>
+              <a:rPr lang="en-GB" sz="1000" dirty="0">
+                <a:solidFill>
+                  <a:srgbClr val="4A5A66"/>
+                </a:solidFill>
+                <a:latin typeface="Calibri"/>
+              </a:rPr>
+              <a:t>models.yaml swap: cloud GPT tiers or local Ollama · BGE-M3 · OCR-VLM</a:t>
+            </a:r>
+          </a:p>
+        </p:txBody>
+      </p:sp>
+      <p:sp>
+        <p:nvSpPr>
+          <p:cNvPr id="206" name="Info 206"/>
+          <p:cNvSpPr/>
+          <p:nvPr/>
+        </p:nvSpPr>
+        <p:spPr>
+          <a:xfrm>
+            <a:off x="825500" y="4330700"/>
+            <a:ext cx="558800" cy="685800"/>
+          </a:xfrm>
+          <a:prstGeom prst="roundRect">
+            <a:avLst/>
+          </a:prstGeom>
+          <a:solidFill>
+            <a:srgbClr val="1F7A8C"/>
+          </a:solidFill>
+          <a:ln>
+            <a:noFill/>
+          </a:ln>
+        </p:spPr>
+        <p:txBody>
+          <a:bodyPr wrap="square" lIns="114300" tIns="50800" rIns="114300" bIns="50800" anchor="ctr">
+            <a:normAutofit/>
+          </a:bodyPr>
+          <a:lstStyle/>
+          <a:p>
+            <a:pPr algn="ctr">
+              <a:buNone/>
+            </a:pPr>
+            <a:r>
+              <a:rPr lang="en-GB" sz="1400" b="1" dirty="0">
+                <a:solidFill>
+                  <a:srgbClr val="FFFFFF"/>
+                </a:solidFill>
+                <a:latin typeface="Calibri"/>
+              </a:rPr>
+              <a:t>04</a:t>
+            </a:r>
+          </a:p>
+        </p:txBody>
+      </p:sp>
+      <p:sp>
+        <p:nvSpPr>
+          <p:cNvPr id="207" name="Info 207"/>
+          <p:cNvSpPr/>
+          <p:nvPr/>
+        </p:nvSpPr>
+        <p:spPr>
+          <a:xfrm>
+            <a:off x="1460500" y="4330700"/>
+            <a:ext cx="4305300" cy="685800"/>
+          </a:xfrm>
+          <a:prstGeom prst="roundRect">
+            <a:avLst/>
+          </a:prstGeom>
+          <a:solidFill>
+            <a:srgbClr val="FFFFFF"/>
+          </a:solidFill>
+          <a:ln>
+            <a:noFill/>
+          </a:ln>
+        </p:spPr>
+        <p:txBody>
+          <a:bodyPr wrap="square" lIns="114300" tIns="50800" rIns="114300" bIns="50800" anchor="ctr">
+            <a:normAutofit/>
+          </a:bodyPr>
+          <a:lstStyle/>
+          <a:p>
+            <a:pPr algn="l">
+              <a:buNone/>
+            </a:pPr>
+            <a:r>
+              <a:rPr lang="en-GB" sz="1400" b="1" dirty="0">
+                <a:solidFill>
+                  <a:srgbClr val="14313D"/>
+                </a:solidFill>
+                <a:latin typeface="Calibri"/>
+              </a:rPr>
+              <a:t>App</a:t>
+            </a:r>
+          </a:p>
+          <a:p>
+            <a:pPr algn="l">
+              <a:buNone/>
+            </a:pPr>
+            <a:r>
+              <a:rPr lang="en-GB" sz="1000" dirty="0">
+                <a:solidFill>
+                  <a:srgbClr val="4A5A66"/>
+                </a:solidFill>
+                <a:latin typeface="Calibri"/>
+              </a:rPr>
+              <a:t>Django + DRF · Next.js / React · PostgreSQL</a:t>
+            </a:r>
+          </a:p>
+        </p:txBody>
+      </p:sp>
+      <p:sp>
+        <p:nvSpPr>
+          <p:cNvPr id="208" name="Info 208"/>
+          <p:cNvSpPr/>
+          <p:nvPr/>
+        </p:nvSpPr>
+        <p:spPr>
+          <a:xfrm>
+            <a:off x="825500" y="5105400"/>
+            <a:ext cx="558800" cy="685800"/>
+          </a:xfrm>
+          <a:prstGeom prst="roundRect">
+            <a:avLst/>
+          </a:prstGeom>
+          <a:solidFill>
+            <a:srgbClr val="1F7A8C"/>
+          </a:solidFill>
+          <a:ln>
+            <a:noFill/>
+          </a:ln>
+        </p:spPr>
+        <p:txBody>
+          <a:bodyPr wrap="square" lIns="114300" tIns="50800" rIns="114300" bIns="50800" anchor="ctr">
+            <a:normAutofit/>
+          </a:bodyPr>
+          <a:lstStyle/>
+          <a:p>
+            <a:pPr algn="ctr">
+              <a:buNone/>
+            </a:pPr>
+            <a:r>
+              <a:rPr lang="en-GB" sz="1400" b="1" dirty="0">
+                <a:solidFill>
+                  <a:srgbClr val="FFFFFF"/>
+                </a:solidFill>
+                <a:latin typeface="Calibri"/>
+              </a:rPr>
+              <a:t>05</a:t>
+            </a:r>
+          </a:p>
+        </p:txBody>
+      </p:sp>
+      <p:sp>
+        <p:nvSpPr>
+          <p:cNvPr id="209" name="Info 209"/>
+          <p:cNvSpPr/>
+          <p:nvPr/>
+        </p:nvSpPr>
+        <p:spPr>
+          <a:xfrm>
+            <a:off x="1460500" y="5105400"/>
+            <a:ext cx="4305300" cy="685800"/>
+          </a:xfrm>
+          <a:prstGeom prst="roundRect">
+            <a:avLst/>
+          </a:prstGeom>
+          <a:solidFill>
+            <a:srgbClr val="FFFFFF"/>
+          </a:solidFill>
+          <a:ln>
+            <a:noFill/>
+          </a:ln>
+        </p:spPr>
+        <p:txBody>
+          <a:bodyPr wrap="square" lIns="114300" tIns="50800" rIns="114300" bIns="50800" anchor="ctr">
+            <a:normAutofit/>
+          </a:bodyPr>
+          <a:lstStyle/>
+          <a:p>
+            <a:pPr algn="l">
+              <a:buNone/>
+            </a:pPr>
+            <a:r>
+              <a:rPr lang="en-GB" sz="1400" b="1" dirty="0">
+                <a:solidFill>
+                  <a:srgbClr val="14313D"/>
+                </a:solidFill>
+                <a:latin typeface="Calibri"/>
+              </a:rPr>
+              <a:t>Ops</a:t>
+            </a:r>
+          </a:p>
+          <a:p>
+            <a:pPr algn="l">
+              <a:buNone/>
+            </a:pPr>
+            <a:r>
+              <a:rPr lang="en-GB" sz="1000" dirty="0">
+                <a:solidFill>
+                  <a:srgbClr val="4A5A66"/>
+                </a:solidFill>
+                <a:latin typeface="Calibri"/>
+              </a:rPr>
+              <a:t>systemd + nginx on plain Linux · Path A runs fully offline</a:t>
+            </a:r>
+          </a:p>
+        </p:txBody>
+      </p:sp>
+      <p:sp>
+        <p:nvSpPr>
+          <p:cNvPr id="210" name="Info 210"/>
+          <p:cNvSpPr/>
+          <p:nvPr/>
+        </p:nvSpPr>
+        <p:spPr>
+          <a:xfrm>
+            <a:off x="825500" y="5943600"/>
+            <a:ext cx="4940300" cy="431800"/>
+          </a:xfrm>
+          <a:prstGeom prst="rect">
+            <a:avLst/>
+          </a:prstGeom>
+          <a:noFill/>
+          <a:ln>
+            <a:noFill/>
+          </a:ln>
+        </p:spPr>
+        <p:txBody>
+          <a:bodyPr wrap="square" lIns="114300" tIns="50800" rIns="114300" bIns="50800" anchor="t" anchorCtr="0">
+            <a:noAutofit/>
+          </a:bodyPr>
+          <a:lstStyle/>
+          <a:p>
+            <a:pPr algn="l">
+              <a:buNone/>
+            </a:pPr>
+            <a:r>
+              <a:rPr lang="en-GB" sz="1100" i="1" dirty="0">
+                <a:solidFill>
+                  <a:srgbClr val="3E4E59"/>
+                </a:solidFill>
+                <a:latin typeface="Calibri"/>
+              </a:rPr>
+              <a:t>All permissive licences (PSF / BSD / MIT / PostgreSQL); pymupdf AGPL used unmodified · no proprietary services required</a:t>
+            </a:r>
+          </a:p>
+        </p:txBody>
+      </p:sp>
+      <p:sp>
+        <p:nvSpPr>
+          <p:cNvPr id="300" name="Diff 300"/>
+          <p:cNvSpPr/>
+          <p:nvPr/>
+        </p:nvSpPr>
+        <p:spPr>
+          <a:xfrm>
+            <a:off x="6578600" y="2006600"/>
+            <a:ext cx="4749800" cy="774700"/>
+          </a:xfrm>
+          <a:prstGeom prst="roundRect">
+            <a:avLst/>
+          </a:prstGeom>
+          <a:solidFill>
+            <a:srgbClr val="FFFFFF"/>
+          </a:solidFill>
+          <a:ln>
+            <a:noFill/>
+          </a:ln>
+        </p:spPr>
+        <p:txBody>
+          <a:bodyPr wrap="square" lIns="127000" tIns="63500" rIns="127000" bIns="63500" anchor="ctr">
+            <a:normAutofit/>
+          </a:bodyPr>
+          <a:lstStyle/>
+          <a:p>
+            <a:pPr>
+              <a:buNone/>
+            </a:pPr>
+            <a:endParaRPr lang="en-GB"/>
+          </a:p>
+        </p:txBody>
+      </p:sp>
+      <p:sp>
+        <p:nvSpPr>
+          <p:cNvPr id="301" name="Diff 301"/>
+          <p:cNvSpPr/>
+          <p:nvPr/>
+        </p:nvSpPr>
+        <p:spPr>
+          <a:xfrm>
+            <a:off x="6578600" y="2006600"/>
+            <a:ext cx="63500" cy="774700"/>
+          </a:xfrm>
+          <a:prstGeom prst="roundRect">
+            <a:avLst/>
+          </a:prstGeom>
+          <a:solidFill>
+            <a:srgbClr val="1F7A8C"/>
+          </a:solidFill>
+          <a:ln>
+            <a:noFill/>
+          </a:ln>
+        </p:spPr>
+        <p:txBody>
+          <a:bodyPr wrap="square" lIns="127000" tIns="63500" rIns="127000" bIns="63500" anchor="ctr">
+            <a:normAutofit/>
+          </a:bodyPr>
+          <a:lstStyle/>
+          <a:p>
+            <a:pPr>
+              <a:buNone/>
+            </a:pPr>
+            <a:endParaRPr lang="en-GB"/>
+          </a:p>
+        </p:txBody>
+      </p:sp>
+      <p:sp>
+        <p:nvSpPr>
+          <p:cNvPr id="302" name="Diff 302"/>
+          <p:cNvSpPr/>
+          <p:nvPr/>
+        </p:nvSpPr>
+        <p:spPr>
+          <a:xfrm>
+            <a:off x="6756400" y="2006600"/>
+            <a:ext cx="4445000" cy="774700"/>
+          </a:xfrm>
+          <a:prstGeom prst="rect">
+            <a:avLst/>
+          </a:prstGeom>
+          <a:noFill/>
+          <a:ln>
+            <a:noFill/>
+          </a:ln>
+        </p:spPr>
+        <p:txBody>
+          <a:bodyPr wrap="square" lIns="127000" tIns="63500" rIns="127000" bIns="63500" anchor="ctr">
+            <a:normAutofit/>
+          </a:bodyPr>
+          <a:lstStyle/>
+          <a:p>
+            <a:pPr algn="l">
+              <a:buNone/>
+            </a:pPr>
+            <a:r>
+              <a:rPr lang="en-GB" sz="1400" b="1" dirty="0">
+                <a:solidFill>
+                  <a:srgbClr val="14313D"/>
+                </a:solidFill>
+                <a:latin typeface="Calibri"/>
+              </a:rPr>
+              <a:t>Proof chain, not just answers</a:t>
+            </a:r>
+          </a:p>
+          <a:p>
+            <a:pPr algn="l">
+              <a:buNone/>
+            </a:pPr>
+            <a:r>
+              <a:rPr lang="en-GB" sz="1000" dirty="0">
+                <a:solidFill>
+                  <a:srgbClr val="4A5A66"/>
+                </a:solidFill>
+                <a:latin typeface="Calibri"/>
+              </a:rPr>
+              <a:t>Every row carries archived bytes + SHA-256 + span-level citation + gate results</a:t>
+            </a:r>
+          </a:p>
+        </p:txBody>
+      </p:sp>
+      <p:sp>
+        <p:nvSpPr>
+          <p:cNvPr id="303" name="Diff 303"/>
+          <p:cNvSpPr/>
+          <p:nvPr/>
+        </p:nvSpPr>
+        <p:spPr>
+          <a:xfrm>
+            <a:off x="6578600" y="2882900"/>
+            <a:ext cx="4749800" cy="774700"/>
+          </a:xfrm>
+          <a:prstGeom prst="roundRect">
+            <a:avLst/>
+          </a:prstGeom>
+          <a:solidFill>
+            <a:srgbClr val="FFFFFF"/>
+          </a:solidFill>
+          <a:ln>
+            <a:noFill/>
+          </a:ln>
+        </p:spPr>
+        <p:txBody>
+          <a:bodyPr wrap="square" lIns="127000" tIns="63500" rIns="127000" bIns="63500" anchor="ctr">
+            <a:normAutofit/>
+          </a:bodyPr>
+          <a:lstStyle/>
+          <a:p>
+            <a:pPr>
+              <a:buNone/>
+            </a:pPr>
+            <a:endParaRPr lang="en-GB"/>
+          </a:p>
+        </p:txBody>
+      </p:sp>
+      <p:sp>
+        <p:nvSpPr>
+          <p:cNvPr id="304" name="Diff 304"/>
+          <p:cNvSpPr/>
+          <p:nvPr/>
+        </p:nvSpPr>
+        <p:spPr>
+          <a:xfrm>
+            <a:off x="6578600" y="2882900"/>
+            <a:ext cx="63500" cy="774700"/>
+          </a:xfrm>
+          <a:prstGeom prst="roundRect">
+            <a:avLst/>
+          </a:prstGeom>
+          <a:solidFill>
+            <a:srgbClr val="1F7A8C"/>
+          </a:solidFill>
+          <a:ln>
+            <a:noFill/>
+          </a:ln>
+        </p:spPr>
+        <p:txBody>
+          <a:bodyPr wrap="square" lIns="127000" tIns="63500" rIns="127000" bIns="63500" anchor="ctr">
+            <a:normAutofit/>
+          </a:bodyPr>
+          <a:lstStyle/>
+          <a:p>
+            <a:pPr>
+              <a:buNone/>
+            </a:pPr>
+            <a:endParaRPr lang="en-GB"/>
+          </a:p>
+        </p:txBody>
+      </p:sp>
+      <p:sp>
+        <p:nvSpPr>
+          <p:cNvPr id="305" name="Diff 305"/>
+          <p:cNvSpPr/>
+          <p:nvPr/>
+        </p:nvSpPr>
+        <p:spPr>
+          <a:xfrm>
+            <a:off x="6756400" y="2882900"/>
+            <a:ext cx="4445000" cy="774700"/>
+          </a:xfrm>
+          <a:prstGeom prst="rect">
+            <a:avLst/>
+          </a:prstGeom>
+          <a:noFill/>
+          <a:ln>
+            <a:noFill/>
+          </a:ln>
+        </p:spPr>
+        <p:txBody>
+          <a:bodyPr wrap="square" lIns="127000" tIns="63500" rIns="127000" bIns="63500" anchor="ctr">
+            <a:normAutofit/>
+          </a:bodyPr>
+          <a:lstStyle/>
+          <a:p>
+            <a:pPr algn="l">
+              <a:buNone/>
+            </a:pPr>
+            <a:r>
+              <a:rPr lang="en-GB" sz="1400" b="1" dirty="0">
+                <a:solidFill>
+                  <a:srgbClr val="14313D"/>
+                </a:solidFill>
+                <a:latin typeface="Calibri"/>
+              </a:rPr>
+              <a:t>Rubric-as-code</a:t>
+            </a:r>
+          </a:p>
+          <a:p>
+            <a:pPr algn="l">
+              <a:buNone/>
+            </a:pPr>
+            <a:r>
+              <a:rPr lang="en-GB" sz="1000" dirty="0">
+                <a:solidFill>
+                  <a:srgbClr val="4A5A66"/>
+                </a:solidFill>
+                <a:latin typeface="Calibri"/>
+              </a:rPr>
+              <a:t>Polarity, 0.5 tiers, exclusions and treaty scoping live in YAML data, never in code</a:t>
+            </a:r>
+          </a:p>
+        </p:txBody>
+      </p:sp>
+      <p:sp>
+        <p:nvSpPr>
+          <p:cNvPr id="306" name="Diff 306"/>
+          <p:cNvSpPr/>
+          <p:nvPr/>
+        </p:nvSpPr>
+        <p:spPr>
+          <a:xfrm>
+            <a:off x="6578600" y="3759200"/>
+            <a:ext cx="4749800" cy="774700"/>
+          </a:xfrm>
+          <a:prstGeom prst="roundRect">
+            <a:avLst/>
+          </a:prstGeom>
+          <a:solidFill>
+            <a:srgbClr val="FFFFFF"/>
+          </a:solidFill>
+          <a:ln>
+            <a:noFill/>
+          </a:ln>
+        </p:spPr>
+        <p:txBody>
+          <a:bodyPr wrap="square" lIns="127000" tIns="63500" rIns="127000" bIns="63500" anchor="ctr">
+            <a:normAutofit/>
+          </a:bodyPr>
+          <a:lstStyle/>
+          <a:p>
+            <a:pPr>
+              <a:buNone/>
+            </a:pPr>
+            <a:endParaRPr lang="en-GB"/>
+          </a:p>
+        </p:txBody>
+      </p:sp>
+      <p:sp>
+        <p:nvSpPr>
+          <p:cNvPr id="307" name="Diff 307"/>
+          <p:cNvSpPr/>
+          <p:nvPr/>
+        </p:nvSpPr>
+        <p:spPr>
+          <a:xfrm>
+            <a:off x="6578600" y="3759200"/>
+            <a:ext cx="63500" cy="774700"/>
+          </a:xfrm>
+          <a:prstGeom prst="roundRect">
+            <a:avLst/>
+          </a:prstGeom>
+          <a:solidFill>
+            <a:srgbClr val="1F7A8C"/>
+          </a:solidFill>
+          <a:ln>
+            <a:noFill/>
+          </a:ln>
+        </p:spPr>
+        <p:txBody>
+          <a:bodyPr wrap="square" lIns="127000" tIns="63500" rIns="127000" bIns="63500" anchor="ctr">
+            <a:normAutofit/>
+          </a:bodyPr>
+          <a:lstStyle/>
+          <a:p>
+            <a:pPr>
+              <a:buNone/>
+            </a:pPr>
+            <a:endParaRPr lang="en-GB"/>
+          </a:p>
+        </p:txBody>
+      </p:sp>
+      <p:sp>
+        <p:nvSpPr>
+          <p:cNvPr id="308" name="Diff 308"/>
+          <p:cNvSpPr/>
+          <p:nvPr/>
+        </p:nvSpPr>
+        <p:spPr>
+          <a:xfrm>
+            <a:off x="6756400" y="3759200"/>
+            <a:ext cx="4445000" cy="774700"/>
+          </a:xfrm>
+          <a:prstGeom prst="rect">
+            <a:avLst/>
+          </a:prstGeom>
+          <a:noFill/>
+          <a:ln>
+            <a:noFill/>
+          </a:ln>
+        </p:spPr>
+        <p:txBody>
+          <a:bodyPr wrap="square" lIns="127000" tIns="63500" rIns="127000" bIns="63500" anchor="ctr">
+            <a:normAutofit/>
+          </a:bodyPr>
+          <a:lstStyle/>
+          <a:p>
+            <a:pPr algn="l">
+              <a:buNone/>
+            </a:pPr>
+            <a:r>
+              <a:rPr lang="en-GB" sz="1400" b="1" dirty="0">
+                <a:solidFill>
+                  <a:srgbClr val="14313D"/>
+                </a:solidFill>
+                <a:latin typeface="Calibri"/>
+              </a:rPr>
+              <a:t>Honest failure</a:t>
+            </a:r>
+          </a:p>
+          <a:p>
+            <a:pPr algn="l">
+              <a:buNone/>
+            </a:pPr>
+            <a:r>
+              <a:rPr lang="en-GB" sz="1000" dirty="0">
+                <a:solidFill>
+                  <a:srgbClr val="4A5A66"/>
+                </a:solidFill>
+                <a:latin typeface="Calibri"/>
+              </a:rPr>
+              <a:t>Dead links become ACQUISITION_UNRESOLVED and BLOCK absence conclusions</a:t>
+            </a:r>
+          </a:p>
+        </p:txBody>
+      </p:sp>
+      <p:sp>
+        <p:nvSpPr>
+          <p:cNvPr id="309" name="Diff 309"/>
+          <p:cNvSpPr/>
+          <p:nvPr/>
+        </p:nvSpPr>
+        <p:spPr>
+          <a:xfrm>
+            <a:off x="6578600" y="4635500"/>
+            <a:ext cx="4749800" cy="774700"/>
+          </a:xfrm>
+          <a:prstGeom prst="roundRect">
+            <a:avLst/>
+          </a:prstGeom>
+          <a:solidFill>
+            <a:srgbClr val="FFFFFF"/>
+          </a:solidFill>
+          <a:ln>
+            <a:noFill/>
+          </a:ln>
+        </p:spPr>
+        <p:txBody>
+          <a:bodyPr wrap="square" lIns="127000" tIns="63500" rIns="127000" bIns="63500" anchor="ctr">
+            <a:normAutofit/>
+          </a:bodyPr>
+          <a:lstStyle/>
+          <a:p>
+            <a:pPr>
+              <a:buNone/>
+            </a:pPr>
+            <a:endParaRPr lang="en-GB"/>
+          </a:p>
+        </p:txBody>
+      </p:sp>
+      <p:sp>
+        <p:nvSpPr>
+          <p:cNvPr id="310" name="Diff 310"/>
+          <p:cNvSpPr/>
+          <p:nvPr/>
+        </p:nvSpPr>
+        <p:spPr>
+          <a:xfrm>
+            <a:off x="6578600" y="4635500"/>
+            <a:ext cx="63500" cy="774700"/>
+          </a:xfrm>
+          <a:prstGeom prst="roundRect">
+            <a:avLst/>
+          </a:prstGeom>
+          <a:solidFill>
+            <a:srgbClr val="1F7A8C"/>
+          </a:solidFill>
+          <a:ln>
+            <a:noFill/>
+          </a:ln>
+        </p:spPr>
+        <p:txBody>
+          <a:bodyPr wrap="square" lIns="127000" tIns="63500" rIns="127000" bIns="63500" anchor="ctr">
+            <a:normAutofit/>
+          </a:bodyPr>
+          <a:lstStyle/>
+          <a:p>
+            <a:pPr>
+              <a:buNone/>
+            </a:pPr>
+            <a:endParaRPr lang="en-GB"/>
+          </a:p>
+        </p:txBody>
+      </p:sp>
+      <p:sp>
+        <p:nvSpPr>
+          <p:cNvPr id="311" name="Diff 311"/>
+          <p:cNvSpPr/>
+          <p:nvPr/>
+        </p:nvSpPr>
+        <p:spPr>
+          <a:xfrm>
+            <a:off x="6756400" y="4635500"/>
+            <a:ext cx="4445000" cy="774700"/>
+          </a:xfrm>
+          <a:prstGeom prst="rect">
+            <a:avLst/>
+          </a:prstGeom>
+          <a:noFill/>
+          <a:ln>
+            <a:noFill/>
+          </a:ln>
+        </p:spPr>
+        <p:txBody>
+          <a:bodyPr wrap="square" lIns="127000" tIns="63500" rIns="127000" bIns="63500" anchor="ctr">
+            <a:normAutofit/>
+          </a:bodyPr>
+          <a:lstStyle/>
+          <a:p>
+            <a:pPr algn="l">
+              <a:buNone/>
+            </a:pPr>
+            <a:r>
+              <a:rPr lang="en-GB" sz="1400" b="1" dirty="0">
+                <a:solidFill>
+                  <a:srgbClr val="14313D"/>
+                </a:solidFill>
+                <a:latin typeface="Calibri"/>
+              </a:rPr>
+              <a:t>Processing fingerprints</a:t>
+            </a:r>
+          </a:p>
+          <a:p>
+            <a:pPr algn="l">
+              <a:buNone/>
+            </a:pPr>
+            <a:r>
+              <a:rPr lang="en-GB" sz="1000" dirty="0">
+                <a:solidFill>
+                  <a:srgbClr val="4A5A66"/>
+                </a:solidFill>
+                <a:latin typeface="Calibri"/>
+              </a:rPr>
+              <a:t>Source sha + extractor version + grammar profile gate every cache reuse</a:t>
+            </a:r>
+          </a:p>
+        </p:txBody>
+      </p:sp>
+      <p:sp>
+        <p:nvSpPr>
+          <p:cNvPr id="312" name="Diff 312"/>
+          <p:cNvSpPr/>
+          <p:nvPr/>
+        </p:nvSpPr>
+        <p:spPr>
+          <a:xfrm>
+            <a:off x="6578600" y="5511800"/>
+            <a:ext cx="4749800" cy="774700"/>
+          </a:xfrm>
+          <a:prstGeom prst="roundRect">
+            <a:avLst/>
+          </a:prstGeom>
+          <a:solidFill>
+            <a:srgbClr val="FFFFFF"/>
+          </a:solidFill>
+          <a:ln>
+            <a:noFill/>
+          </a:ln>
+        </p:spPr>
+        <p:txBody>
+          <a:bodyPr wrap="square" lIns="127000" tIns="63500" rIns="127000" bIns="63500" anchor="ctr">
+            <a:normAutofit/>
+          </a:bodyPr>
+          <a:lstStyle/>
+          <a:p>
+            <a:pPr>
+              <a:buNone/>
+            </a:pPr>
+            <a:endParaRPr lang="en-GB"/>
+          </a:p>
+        </p:txBody>
+      </p:sp>
+      <p:sp>
+        <p:nvSpPr>
+          <p:cNvPr id="313" name="Diff 313"/>
+          <p:cNvSpPr/>
+          <p:nvPr/>
+        </p:nvSpPr>
+        <p:spPr>
+          <a:xfrm>
+            <a:off x="6578600" y="5511800"/>
+            <a:ext cx="63500" cy="774700"/>
+          </a:xfrm>
+          <a:prstGeom prst="roundRect">
+            <a:avLst/>
+          </a:prstGeom>
+          <a:solidFill>
+            <a:srgbClr val="1F7A8C"/>
+          </a:solidFill>
+          <a:ln>
+            <a:noFill/>
+          </a:ln>
+        </p:spPr>
+        <p:txBody>
+          <a:bodyPr wrap="square" lIns="127000" tIns="63500" rIns="127000" bIns="63500" anchor="ctr">
+            <a:normAutofit/>
+          </a:bodyPr>
+          <a:lstStyle/>
+          <a:p>
+            <a:pPr>
+              <a:buNone/>
+            </a:pPr>
+            <a:endParaRPr lang="en-GB"/>
+          </a:p>
+        </p:txBody>
+      </p:sp>
+      <p:sp>
+        <p:nvSpPr>
+          <p:cNvPr id="314" name="Diff 314"/>
+          <p:cNvSpPr/>
+          <p:nvPr/>
+        </p:nvSpPr>
+        <p:spPr>
+          <a:xfrm>
+            <a:off x="6756400" y="5511800"/>
+            <a:ext cx="4445000" cy="774700"/>
+          </a:xfrm>
+          <a:prstGeom prst="rect">
+            <a:avLst/>
+          </a:prstGeom>
+          <a:noFill/>
+          <a:ln>
+            <a:noFill/>
+          </a:ln>
+        </p:spPr>
+        <p:txBody>
+          <a:bodyPr wrap="square" lIns="127000" tIns="63500" rIns="127000" bIns="63500" anchor="ctr">
+            <a:normAutofit/>
+          </a:bodyPr>
+          <a:lstStyle/>
+          <a:p>
+            <a:pPr algn="l">
+              <a:buNone/>
+            </a:pPr>
+            <a:r>
+              <a:rPr lang="en-GB" sz="1400" b="1" dirty="0">
+                <a:solidFill>
+                  <a:srgbClr val="14313D"/>
+                </a:solidFill>
+                <a:latin typeface="Calibri"/>
+              </a:rPr>
+              <a:t>Gold-audit tripwire</a:t>
+            </a:r>
+          </a:p>
+          <a:p>
+            <a:pPr algn="l">
+              <a:buNone/>
+            </a:pPr>
+            <a:r>
+              <a:rPr lang="en-GB" sz="1000" dirty="0">
+                <a:solidFill>
+                  <a:srgbClr val="4A5A66"/>
+                </a:solidFill>
+                <a:latin typeface="Calibri"/>
+              </a:rPr>
+              <a:t>Detected planted errors in the provided Malaysia gold data; filed corrections with receipts</a:t>
+            </a:r>
+          </a:p>
+        </p:txBody>
+      </p:sp>
     </p:spTree>
+    <p:extLst>
+      <p:ext uri="{BB962C8B-B14F-4D97-AF65-F5344CB8AC3E}">
+        <p14:creationId xmlns:p14="http://schemas.microsoft.com/office/powerpoint/2010/main" val="3738535777"/>
+      </p:ext>
+    </p:extLst>
   </p:cSld>
   <p:clrMapOvr>
     <a:masterClrMapping/>
@@ -18036,7 +18957,7 @@
                 <a:ea typeface="Titillium Web" pitchFamily="34" charset="-122"/>
                 <a:cs typeface="Titillium Web" pitchFamily="34" charset="-120"/>
               </a:rPr>
-              <a:t>53,969</a:t>
+              <a:t>68,686</a:t>
             </a:r>
             <a:endParaRPr lang="en-US" sz="4400" dirty="0"/>
           </a:p>
@@ -18075,7 +18996,7 @@
                 <a:ea typeface="Calibri" pitchFamily="34" charset="-122"/>
                 <a:cs typeface="Calibri" pitchFamily="34" charset="-120"/>
               </a:rPr>
-              <a:t>provisions in the judged corpus (SG 10,494 · MY 3,688 · AU 39,787)</a:t>
+              <a:t>provisions across six economies (SG · MY · AU · TH · IN · ID), parsed to subsection depth</a:t>
             </a:r>
             <a:endParaRPr lang="en-US" sz="1050" dirty="0"/>
           </a:p>
@@ -18236,7 +19157,7 @@
                 <a:ea typeface="Titillium Web" pitchFamily="34" charset="-122"/>
                 <a:cs typeface="Titillium Web" pitchFamily="34" charset="-120"/>
               </a:rPr>
-              <a:t>74</a:t>
+              <a:t>167</a:t>
             </a:r>
             <a:endParaRPr lang="en-US" sz="4400" dirty="0"/>
           </a:p>
@@ -18275,7 +19196,7 @@
                 <a:ea typeface="Calibri" pitchFamily="34" charset="-122"/>
                 <a:cs typeface="Calibri" pitchFamily="34" charset="-120"/>
               </a:rPr>
-              <a:t>provision-level NEW findings discovered beyond the sample kit in the final sweep</a:t>
+              <a:t>provision-level NEW candidates across six economies — 96 already through named human review</a:t>
             </a:r>
             <a:endParaRPr lang="en-US" sz="1050" dirty="0"/>
           </a:p>
@@ -18336,7 +19257,7 @@
                 <a:ea typeface="Titillium Web" pitchFamily="34" charset="-122"/>
                 <a:cs typeface="Titillium Web" pitchFamily="34" charset="-120"/>
               </a:rPr>
-              <a:t>148</a:t>
+              <a:t>211</a:t>
             </a:r>
             <a:endParaRPr lang="en-US" sz="4400" dirty="0"/>
           </a:p>
@@ -18375,7 +19296,7 @@
                 <a:ea typeface="Calibri" pitchFamily="34" charset="-122"/>
                 <a:cs typeface="Calibri" pitchFamily="34" charset="-120"/>
               </a:rPr>
-              <a:t>automated tests green, incl. builder-level integration and champion-contract suites</a:t>
+              <a:t>automated tests green across engine and web app, incl. real-writer integration suites</a:t>
             </a:r>
             <a:endParaRPr lang="en-US" sz="1050" dirty="0"/>
           </a:p>
@@ -19189,4 +20110,26 @@
     </a:ext>
   </a:extLst>
 </a:theme>
+</file>
+
+<file path=ppt/webextensions/taskpanes.xml><?xml version="1.0" encoding="utf-8"?>
+<wetp:taskpanes xmlns:wetp="http://schemas.microsoft.com/office/webextensions/taskpanes/2010/11">
+  <wetp:taskpane dockstate="right" visibility="0" width="350" row="0">
+    <wetp:webextensionref xmlns:r="http://schemas.openxmlformats.org/officeDocument/2006/relationships" r:id="rId1"/>
+  </wetp:taskpane>
+</wetp:taskpanes>
+</file>
+
+<file path=ppt/webextensions/webextension1.xml><?xml version="1.0" encoding="utf-8"?>
+<we:webextension xmlns:we="http://schemas.microsoft.com/office/webextensions/webextension/2010/11" id="{4AA2DD12-C9BD-8743-B21F-E77E78D2B859}">
+  <we:reference id="wa200010001" version="1.0.0.1" store="en-US" storeType="OMEX"/>
+  <we:alternateReferences>
+    <we:reference id="WA200010001" version="1.0.0.1" store="" storeType="OMEX"/>
+  </we:alternateReferences>
+  <we:properties>
+    <we:property name="claude.fileId" value="&quot;6c7206ee-a12d-4ee1-ad6f-6664656f03ef&quot;"/>
+  </we:properties>
+  <we:bindings/>
+  <we:snapshot xmlns:r="http://schemas.openxmlformats.org/officeDocument/2006/relationships"/>
+</we:webextension>
 </file>
</xml_diff>